<commit_message>
add pptx to png convert
</commit_message>
<xml_diff>
--- a/backend/template/template1.pptx
+++ b/backend/template/template1.pptx
@@ -3951,7 +3951,7 @@
         <p:spPr>
           <a:xfrm>
             <a:off x="4521001" y="7906509"/>
-            <a:ext cx="4305344" cy="1246880"/>
+            <a:ext cx="4305344" cy="823687"/>
           </a:xfrm>
           <a:prstGeom prst="rect">
             <a:avLst/>
@@ -3978,7 +3978,7 @@
                 <a:cs typeface="Bai Jamjuree"/>
                 <a:sym typeface="Bai Jamjuree"/>
               </a:rPr>
-              <a:t>{{Call out text e.g. “read more”, size max. 27, 2 rows}}</a:t>
+              <a:t>{{Call out text e.g. read more, size max. 27, 2 rows}}</a:t>
             </a:r>
           </a:p>
         </p:txBody>

</xml_diff>